<commit_message>
Update comparativa_optimizadores_v2.pptx: add dummy explanations per module
</commit_message>
<xml_diff>
--- a/comparativa_optimizadores_v2.pptx
+++ b/comparativa_optimizadores_v2.pptx
@@ -24,6 +24,12 @@
     <p:sldId id="272" r:id="rId23"/>
     <p:sldId id="273" r:id="rId24"/>
     <p:sldId id="274" r:id="rId25"/>
+    <p:sldId id="275" r:id="rId26"/>
+    <p:sldId id="276" r:id="rId27"/>
+    <p:sldId id="277" r:id="rId28"/>
+    <p:sldId id="278" r:id="rId29"/>
+    <p:sldId id="279" r:id="rId30"/>
+    <p:sldId id="280" r:id="rId31"/>
   </p:sldIdLst>
   <p:sldSz cx="12188952" cy="6858000" type="screen4x3"/>
   <p:notesSz cx="6858000" cy="9144000"/>
@@ -8722,6 +8728,2434 @@
                 </a:solidFill>
               </a:rPr>
               <a:t>★ Mejor resultado global (−24% vs línea base ~270 días)  ·  M11/M12: proceso colapsó por limitación de recursos en nube  ·  M14: no mejoró línea base</a:t>
+            </a:r>
+          </a:p>
+        </p:txBody>
+      </p:sp>
+    </p:spTree>
+  </p:cSld>
+  <p:clrMapOvr>
+    <a:masterClrMapping/>
+  </p:clrMapOvr>
+</p:sld>
+</file>
+
+<file path=ppt/slides/slide20.xml><?xml version="1.0" encoding="utf-8"?>
+<p:sld xmlns:a="http://schemas.openxmlformats.org/drawingml/2006/main" xmlns:p="http://schemas.openxmlformats.org/presentationml/2006/main" xmlns:r="http://schemas.openxmlformats.org/officeDocument/2006/relationships">
+  <p:cSld>
+    <p:bg>
+      <p:bgPr>
+        <a:solidFill>
+          <a:srgbClr val="D9EAF7"/>
+        </a:solidFill>
+        <a:effectLst/>
+      </p:bgPr>
+    </p:bg>
+    <p:spTree>
+      <p:nvGrpSpPr>
+        <p:cNvPr id="1" name=""/>
+        <p:cNvGrpSpPr/>
+        <p:nvPr/>
+      </p:nvGrpSpPr>
+      <p:grpSpPr/>
+      <p:sp>
+        <p:nvSpPr>
+          <p:cNvPr id="2" name="Rectangle 1"/>
+          <p:cNvSpPr/>
+          <p:nvPr/>
+        </p:nvSpPr>
+        <p:spPr>
+          <a:xfrm>
+            <a:off x="0" y="0"/>
+            <a:ext cx="12188952" cy="1188720"/>
+          </a:xfrm>
+          <a:prstGeom prst="rect">
+            <a:avLst/>
+          </a:prstGeom>
+          <a:solidFill>
+            <a:srgbClr val="1F497D"/>
+          </a:solidFill>
+          <a:ln>
+            <a:noFill/>
+          </a:ln>
+        </p:spPr>
+        <p:style>
+          <a:lnRef idx="1">
+            <a:schemeClr val="accent1"/>
+          </a:lnRef>
+          <a:fillRef idx="3">
+            <a:schemeClr val="accent1"/>
+          </a:fillRef>
+          <a:effectRef idx="2">
+            <a:schemeClr val="accent1"/>
+          </a:effectRef>
+          <a:fontRef idx="minor">
+            <a:schemeClr val="lt1"/>
+          </a:fontRef>
+        </p:style>
+        <p:txBody>
+          <a:bodyPr rtlCol="0" anchor="ctr" wrap="square" tIns="76200" lIns="274320"/>
+          <a:lstStyle/>
+          <a:p>
+            <a:pPr algn="l"/>
+            <a:r>
+              <a:rPr b="1" sz="2400">
+                <a:solidFill>
+                  <a:srgbClr val="FFFFFF"/>
+                </a:solidFill>
+              </a:rPr>
+              <a:t>M4 — SMAC BlackBox — GP + EI</a:t>
+            </a:r>
+          </a:p>
+          <a:p>
+            <a:pPr algn="l"/>
+            <a:r>
+              <a:rPr b="0" sz="1300">
+                <a:solidFill>
+                  <a:srgbClr val="BDD7EE"/>
+                </a:solidFill>
+              </a:rPr>
+              <a:t>Paper: Hutter, Hoos &amp; Leyton-Brown (2011) — «Sequential Model-Based Optimization for General Algo…</a:t>
+            </a:r>
+          </a:p>
+        </p:txBody>
+      </p:sp>
+      <p:sp>
+        <p:nvSpPr>
+          <p:cNvPr id="3" name="TextBox 2"/>
+          <p:cNvSpPr txBox="1"/>
+          <p:nvPr/>
+        </p:nvSpPr>
+        <p:spPr>
+          <a:xfrm>
+            <a:off x="274320" y="1261872"/>
+            <a:ext cx="11640312" cy="457200"/>
+          </a:xfrm>
+          <a:prstGeom prst="rect">
+            <a:avLst/>
+          </a:prstGeom>
+          <a:noFill/>
+        </p:spPr>
+        <p:txBody>
+          <a:bodyPr wrap="square">
+            <a:spAutoFit/>
+          </a:bodyPr>
+          <a:lstStyle/>
+          <a:p>
+            <a:pPr algn="ctr"/>
+            <a:r>
+              <a:rPr b="1" sz="1300">
+                <a:solidFill>
+                  <a:srgbClr val="1F497D"/>
+                </a:solidFill>
+              </a:rPr>
+              <a:t>Analogía: Un catador de vinos que aprende tus preferencias</a:t>
+            </a:r>
+          </a:p>
+        </p:txBody>
+      </p:sp>
+      <p:sp>
+        <p:nvSpPr>
+          <p:cNvPr id="4" name="TextBox 3"/>
+          <p:cNvSpPr txBox="1"/>
+          <p:nvPr/>
+        </p:nvSpPr>
+        <p:spPr>
+          <a:xfrm>
+            <a:off x="274320" y="1719072"/>
+            <a:ext cx="7223760" cy="2834640"/>
+          </a:xfrm>
+          <a:prstGeom prst="rect">
+            <a:avLst/>
+          </a:prstGeom>
+          <a:noFill/>
+        </p:spPr>
+        <p:txBody>
+          <a:bodyPr wrap="square">
+            <a:spAutoFit/>
+          </a:bodyPr>
+          <a:lstStyle/>
+          <a:p>
+            <a:pPr algn="l"/>
+            <a:r>
+              <a:rPr b="1" sz="1100">
+                <a:solidFill>
+                  <a:srgbClr val="1F497D"/>
+                </a:solidFill>
+              </a:rPr>
+              <a:t>¿Cómo funciona? (versión simple)</a:t>
+            </a:r>
+          </a:p>
+          <a:p>
+            <a:pPr algn="l"/>
+            <a:r>
+              <a:rPr b="0" sz="1050">
+                <a:solidFill>
+                  <a:srgbClr val="404040"/>
+                </a:solidFill>
+              </a:rPr>
+              <a:t>Imagina que quieres encontrar la mejor receta de un plato pero cocinar es muy caro.
+SMAC prueba unas pocas recetas, construye un 'mapa mental' de cuáles son buenas,
+y elige la siguiente receta a probar donde cree que puede haber una sorpresa positiva.
+El 'mapa mental' es un modelo gaussiano (GP) que predice qué tan bueno será cada ingrediente.</a:t>
+            </a:r>
+          </a:p>
+        </p:txBody>
+      </p:sp>
+      <p:sp>
+        <p:nvSpPr>
+          <p:cNvPr id="5" name="TextBox 4"/>
+          <p:cNvSpPr txBox="1"/>
+          <p:nvPr/>
+        </p:nvSpPr>
+        <p:spPr>
+          <a:xfrm>
+            <a:off x="7680960" y="1719072"/>
+            <a:ext cx="4297680" cy="4846320"/>
+          </a:xfrm>
+          <a:prstGeom prst="rect">
+            <a:avLst/>
+          </a:prstGeom>
+          <a:noFill/>
+        </p:spPr>
+        <p:txBody>
+          <a:bodyPr wrap="square">
+            <a:spAutoFit/>
+          </a:bodyPr>
+          <a:lstStyle/>
+          <a:p>
+            <a:pPr algn="l"/>
+            <a:r>
+              <a:rPr b="1" sz="1050">
+                <a:solidFill>
+                  <a:srgbClr val="1F497D"/>
+                </a:solidFill>
+              </a:rPr>
+              <a:t>¿Cuándo usar?</a:t>
+            </a:r>
+          </a:p>
+          <a:p>
+            <a:pPr algn="l"/>
+            <a:r>
+              <a:rPr b="0" sz="1000">
+                <a:solidFill>
+                  <a:srgbClr val="404040"/>
+                </a:solidFill>
+              </a:rPr>
+              <a:t>Pocos recursos de simulación (≤50 evaluaciones), muchas variables, función muy ruidosa.</a:t>
+            </a:r>
+          </a:p>
+          <a:p>
+            <a:pPr algn="l"/>
+            <a:r>
+              <a:rPr b="0" sz="600">
+                <a:solidFill>
+                  <a:srgbClr val="404040"/>
+                </a:solidFill>
+              </a:rPr>
+              <a:t> </a:t>
+            </a:r>
+          </a:p>
+          <a:p>
+            <a:pPr algn="l"/>
+            <a:r>
+              <a:rPr b="1" sz="1050">
+                <a:solidFill>
+                  <a:srgbClr val="378648"/>
+                </a:solidFill>
+              </a:rPr>
+              <a:t>Fortaleza</a:t>
+            </a:r>
+          </a:p>
+          <a:p>
+            <a:pPr algn="l"/>
+            <a:r>
+              <a:rPr b="0" sz="1000">
+                <a:solidFill>
+                  <a:srgbClr val="404040"/>
+                </a:solidFill>
+              </a:rPr>
+              <a:t>Muy eficiente: mejora mucho con pocas pruebas. El más rápido en converger.</a:t>
+            </a:r>
+          </a:p>
+          <a:p>
+            <a:pPr algn="l"/>
+            <a:r>
+              <a:rPr b="0" sz="600">
+                <a:solidFill>
+                  <a:srgbClr val="404040"/>
+                </a:solidFill>
+              </a:rPr>
+              <a:t> </a:t>
+            </a:r>
+          </a:p>
+          <a:p>
+            <a:pPr algn="l"/>
+            <a:r>
+              <a:rPr b="1" sz="1050">
+                <a:solidFill>
+                  <a:srgbClr val="C55A11"/>
+                </a:solidFill>
+              </a:rPr>
+              <a:t>Debilidad</a:t>
+            </a:r>
+          </a:p>
+          <a:p>
+            <a:pPr algn="l"/>
+            <a:r>
+              <a:rPr b="0" sz="1000">
+                <a:solidFill>
+                  <a:srgbClr val="404040"/>
+                </a:solidFill>
+              </a:rPr>
+              <a:t>El modelo GP no escala bien a más de ~20 variables. Asume cierta suavidad.</a:t>
+            </a:r>
+          </a:p>
+          <a:p>
+            <a:pPr algn="l"/>
+            <a:r>
+              <a:rPr b="0" sz="600">
+                <a:solidFill>
+                  <a:srgbClr val="404040"/>
+                </a:solidFill>
+              </a:rPr>
+              <a:t> </a:t>
+            </a:r>
+          </a:p>
+          <a:p>
+            <a:pPr algn="l"/>
+            <a:r>
+              <a:rPr b="1" sz="1050">
+                <a:solidFill>
+                  <a:srgbClr val="404040"/>
+                </a:solidFill>
+              </a:rPr>
+              <a:t>Resultado obtenido</a:t>
+            </a:r>
+          </a:p>
+          <a:p>
+            <a:pPr algn="l"/>
+            <a:r>
+              <a:rPr b="0" sz="1000">
+                <a:solidFill>
+                  <a:srgbClr val="404040"/>
+                </a:solidFill>
+              </a:rPr>
+              <a:t>205.17 días — MEJOR resultado con solo 20 evaluaciones y 1.3h.</a:t>
+            </a:r>
+          </a:p>
+          <a:p>
+            <a:pPr algn="l"/>
+            <a:r>
+              <a:rPr b="0" sz="600">
+                <a:solidFill>
+                  <a:srgbClr val="404040"/>
+                </a:solidFill>
+              </a:rPr>
+              <a:t> </a:t>
+            </a:r>
+          </a:p>
+        </p:txBody>
+      </p:sp>
+      <p:sp>
+        <p:nvSpPr>
+          <p:cNvPr id="6" name="Rectangle 5"/>
+          <p:cNvSpPr/>
+          <p:nvPr/>
+        </p:nvSpPr>
+        <p:spPr>
+          <a:xfrm>
+            <a:off x="7543800" y="1719072"/>
+            <a:ext cx="36576" cy="4892040"/>
+          </a:xfrm>
+          <a:prstGeom prst="rect">
+            <a:avLst/>
+          </a:prstGeom>
+          <a:solidFill>
+            <a:srgbClr val="1F497D"/>
+          </a:solidFill>
+          <a:ln>
+            <a:noFill/>
+          </a:ln>
+        </p:spPr>
+        <p:style>
+          <a:lnRef idx="1">
+            <a:schemeClr val="accent1"/>
+          </a:lnRef>
+          <a:fillRef idx="3">
+            <a:schemeClr val="accent1"/>
+          </a:fillRef>
+          <a:effectRef idx="2">
+            <a:schemeClr val="accent1"/>
+          </a:effectRef>
+          <a:fontRef idx="minor">
+            <a:schemeClr val="lt1"/>
+          </a:fontRef>
+        </p:style>
+        <p:txBody>
+          <a:bodyPr rtlCol="0" anchor="ctr"/>
+          <a:lstStyle/>
+          <a:p>
+            <a:pPr algn="ctr"/>
+          </a:p>
+        </p:txBody>
+      </p:sp>
+      <p:sp>
+        <p:nvSpPr>
+          <p:cNvPr id="7" name="TextBox 6"/>
+          <p:cNvSpPr txBox="1"/>
+          <p:nvPr/>
+        </p:nvSpPr>
+        <p:spPr>
+          <a:xfrm>
+            <a:off x="274320" y="4663440"/>
+            <a:ext cx="7223760" cy="594360"/>
+          </a:xfrm>
+          <a:prstGeom prst="rect">
+            <a:avLst/>
+          </a:prstGeom>
+          <a:noFill/>
+        </p:spPr>
+        <p:txBody>
+          <a:bodyPr wrap="square">
+            <a:spAutoFit/>
+          </a:bodyPr>
+          <a:lstStyle/>
+          <a:p>
+            <a:pPr algn="l"/>
+            <a:r>
+              <a:rPr b="0" sz="850">
+                <a:solidFill>
+                  <a:srgbClr val="808080"/>
+                </a:solidFill>
+              </a:rPr>
+              <a:t>Referencia: Hutter, Hoos &amp; Leyton-Brown (2011) — «Sequential Model-Based Optimization for General Algorithm Configuration» — JAIR</a:t>
+            </a:r>
+          </a:p>
+        </p:txBody>
+      </p:sp>
+    </p:spTree>
+  </p:cSld>
+  <p:clrMapOvr>
+    <a:masterClrMapping/>
+  </p:clrMapOvr>
+</p:sld>
+</file>
+
+<file path=ppt/slides/slide21.xml><?xml version="1.0" encoding="utf-8"?>
+<p:sld xmlns:a="http://schemas.openxmlformats.org/drawingml/2006/main" xmlns:p="http://schemas.openxmlformats.org/presentationml/2006/main" xmlns:r="http://schemas.openxmlformats.org/officeDocument/2006/relationships">
+  <p:cSld>
+    <p:bg>
+      <p:bgPr>
+        <a:solidFill>
+          <a:srgbClr val="C5DEF2"/>
+        </a:solidFill>
+        <a:effectLst/>
+      </p:bgPr>
+    </p:bg>
+    <p:spTree>
+      <p:nvGrpSpPr>
+        <p:cNvPr id="1" name=""/>
+        <p:cNvGrpSpPr/>
+        <p:nvPr/>
+      </p:nvGrpSpPr>
+      <p:grpSpPr/>
+      <p:sp>
+        <p:nvSpPr>
+          <p:cNvPr id="2" name="Rectangle 1"/>
+          <p:cNvSpPr/>
+          <p:nvPr/>
+        </p:nvSpPr>
+        <p:spPr>
+          <a:xfrm>
+            <a:off x="0" y="0"/>
+            <a:ext cx="12188952" cy="1188720"/>
+          </a:xfrm>
+          <a:prstGeom prst="rect">
+            <a:avLst/>
+          </a:prstGeom>
+          <a:solidFill>
+            <a:srgbClr val="1F497D"/>
+          </a:solidFill>
+          <a:ln>
+            <a:noFill/>
+          </a:ln>
+        </p:spPr>
+        <p:style>
+          <a:lnRef idx="1">
+            <a:schemeClr val="accent1"/>
+          </a:lnRef>
+          <a:fillRef idx="3">
+            <a:schemeClr val="accent1"/>
+          </a:fillRef>
+          <a:effectRef idx="2">
+            <a:schemeClr val="accent1"/>
+          </a:effectRef>
+          <a:fontRef idx="minor">
+            <a:schemeClr val="lt1"/>
+          </a:fontRef>
+        </p:style>
+        <p:txBody>
+          <a:bodyPr rtlCol="0" anchor="ctr" wrap="square" tIns="76200" lIns="274320"/>
+          <a:lstStyle/>
+          <a:p>
+            <a:pPr algn="l"/>
+            <a:r>
+              <a:rPr b="1" sz="2400">
+                <a:solidFill>
+                  <a:srgbClr val="FFFFFF"/>
+                </a:solidFill>
+              </a:rPr>
+              <a:t>M7–M10 — SMAC + Stochastic Kriging (SK Variants)</a:t>
+            </a:r>
+          </a:p>
+          <a:p>
+            <a:pPr algn="l"/>
+            <a:r>
+              <a:rPr b="0" sz="1300">
+                <a:solidFill>
+                  <a:srgbClr val="BDD7EE"/>
+                </a:solidFill>
+              </a:rPr>
+              <a:t>Paper: Ankenman, Nelson &amp; Staum (2010) — «Stochastic Kriging for Simulation Metamodeling» — Manag…</a:t>
+            </a:r>
+          </a:p>
+        </p:txBody>
+      </p:sp>
+      <p:sp>
+        <p:nvSpPr>
+          <p:cNvPr id="3" name="TextBox 2"/>
+          <p:cNvSpPr txBox="1"/>
+          <p:nvPr/>
+        </p:nvSpPr>
+        <p:spPr>
+          <a:xfrm>
+            <a:off x="274320" y="1261872"/>
+            <a:ext cx="11640312" cy="457200"/>
+          </a:xfrm>
+          <a:prstGeom prst="rect">
+            <a:avLst/>
+          </a:prstGeom>
+          <a:noFill/>
+        </p:spPr>
+        <p:txBody>
+          <a:bodyPr wrap="square">
+            <a:spAutoFit/>
+          </a:bodyPr>
+          <a:lstStyle/>
+          <a:p>
+            <a:pPr algn="ctr"/>
+            <a:r>
+              <a:rPr b="1" sz="1300">
+                <a:solidFill>
+                  <a:srgbClr val="1F497D"/>
+                </a:solidFill>
+              </a:rPr>
+              <a:t>Analogía: Un catador experto que sabe exactamente cuánto varía la calidad del vino de botella a botella</a:t>
+            </a:r>
+          </a:p>
+        </p:txBody>
+      </p:sp>
+      <p:sp>
+        <p:nvSpPr>
+          <p:cNvPr id="4" name="TextBox 3"/>
+          <p:cNvSpPr txBox="1"/>
+          <p:nvPr/>
+        </p:nvSpPr>
+        <p:spPr>
+          <a:xfrm>
+            <a:off x="274320" y="1719072"/>
+            <a:ext cx="7223760" cy="2834640"/>
+          </a:xfrm>
+          <a:prstGeom prst="rect">
+            <a:avLst/>
+          </a:prstGeom>
+          <a:noFill/>
+        </p:spPr>
+        <p:txBody>
+          <a:bodyPr wrap="square">
+            <a:spAutoFit/>
+          </a:bodyPr>
+          <a:lstStyle/>
+          <a:p>
+            <a:pPr algn="l"/>
+            <a:r>
+              <a:rPr b="1" sz="1100">
+                <a:solidFill>
+                  <a:srgbClr val="1F497D"/>
+                </a:solidFill>
+              </a:rPr>
+              <a:t>¿Cómo funciona? (versión simple)</a:t>
+            </a:r>
+          </a:p>
+          <a:p>
+            <a:pPr algn="l"/>
+            <a:r>
+              <a:rPr b="0" sz="1050">
+                <a:solidFill>
+                  <a:srgbClr val="404040"/>
+                </a:solidFill>
+              </a:rPr>
+              <a:t>La diferencia con M4 es que el simulador es ruidoso: la misma receta da resultados distintos
+cada vez que la cocinas. SK es como el GP pero también modela cuánto varía el ruido
+según dónde estás en el espacio de búsqueda (ruido heteroscedástico).
+• M8 SK-Adaptativo: ajusta automáticamente la 'confianza' en cada zona.
+• M9 SK-REVI: elige próximo punto según el valor esperado de la información nueva.
+• M10 SK-KGCP: mira un paso adelante — ¿dónde conviene probar para aprender más?
+• M7 combina SK con la mecánica de SMAC (Expected Improvement clásico).</a:t>
+            </a:r>
+          </a:p>
+        </p:txBody>
+      </p:sp>
+      <p:sp>
+        <p:nvSpPr>
+          <p:cNvPr id="5" name="TextBox 4"/>
+          <p:cNvSpPr txBox="1"/>
+          <p:nvPr/>
+        </p:nvSpPr>
+        <p:spPr>
+          <a:xfrm>
+            <a:off x="7680960" y="1719072"/>
+            <a:ext cx="4297680" cy="4846320"/>
+          </a:xfrm>
+          <a:prstGeom prst="rect">
+            <a:avLst/>
+          </a:prstGeom>
+          <a:noFill/>
+        </p:spPr>
+        <p:txBody>
+          <a:bodyPr wrap="square">
+            <a:spAutoFit/>
+          </a:bodyPr>
+          <a:lstStyle/>
+          <a:p>
+            <a:pPr algn="l"/>
+            <a:r>
+              <a:rPr b="1" sz="1050">
+                <a:solidFill>
+                  <a:srgbClr val="1F497D"/>
+                </a:solidFill>
+              </a:rPr>
+              <a:t>¿Cuándo usar?</a:t>
+            </a:r>
+          </a:p>
+          <a:p>
+            <a:pPr algn="l"/>
+            <a:r>
+              <a:rPr b="0" sz="1000">
+                <a:solidFill>
+                  <a:srgbClr val="404040"/>
+                </a:solidFill>
+              </a:rPr>
+              <a:t>Simuladores ruidosos donde el mismo punto da resultados distintos. Presupuesto moderado (20–100 eval).</a:t>
+            </a:r>
+          </a:p>
+          <a:p>
+            <a:pPr algn="l"/>
+            <a:r>
+              <a:rPr b="0" sz="600">
+                <a:solidFill>
+                  <a:srgbClr val="404040"/>
+                </a:solidFill>
+              </a:rPr>
+              <a:t> </a:t>
+            </a:r>
+          </a:p>
+          <a:p>
+            <a:pPr algn="l"/>
+            <a:r>
+              <a:rPr b="1" sz="1050">
+                <a:solidFill>
+                  <a:srgbClr val="378648"/>
+                </a:solidFill>
+              </a:rPr>
+              <a:t>Fortaleza</a:t>
+            </a:r>
+          </a:p>
+          <a:p>
+            <a:pPr algn="l"/>
+            <a:r>
+              <a:rPr b="0" sz="1000">
+                <a:solidFill>
+                  <a:srgbClr val="404040"/>
+                </a:solidFill>
+              </a:rPr>
+              <a:t>Modela el ruido explícitamente → mejores decisiones en regiones inciertas.</a:t>
+            </a:r>
+          </a:p>
+          <a:p>
+            <a:pPr algn="l"/>
+            <a:r>
+              <a:rPr b="0" sz="600">
+                <a:solidFill>
+                  <a:srgbClr val="404040"/>
+                </a:solidFill>
+              </a:rPr>
+              <a:t> </a:t>
+            </a:r>
+          </a:p>
+          <a:p>
+            <a:pPr algn="l"/>
+            <a:r>
+              <a:rPr b="1" sz="1050">
+                <a:solidFill>
+                  <a:srgbClr val="C55A11"/>
+                </a:solidFill>
+              </a:rPr>
+              <a:t>Debilidad</a:t>
+            </a:r>
+          </a:p>
+          <a:p>
+            <a:pPr algn="l"/>
+            <a:r>
+              <a:rPr b="0" sz="1000">
+                <a:solidFill>
+                  <a:srgbClr val="404040"/>
+                </a:solidFill>
+              </a:rPr>
+              <a:t>Más complejo que GP. Con solo 20 evaluaciones no siempre supera a M4.</a:t>
+            </a:r>
+          </a:p>
+          <a:p>
+            <a:pPr algn="l"/>
+            <a:r>
+              <a:rPr b="0" sz="600">
+                <a:solidFill>
+                  <a:srgbClr val="404040"/>
+                </a:solidFill>
+              </a:rPr>
+              <a:t> </a:t>
+            </a:r>
+          </a:p>
+          <a:p>
+            <a:pPr algn="l"/>
+            <a:r>
+              <a:rPr b="1" sz="1050">
+                <a:solidFill>
+                  <a:srgbClr val="404040"/>
+                </a:solidFill>
+              </a:rPr>
+              <a:t>Resultado obtenido</a:t>
+            </a:r>
+          </a:p>
+          <a:p>
+            <a:pPr algn="l"/>
+            <a:r>
+              <a:rPr b="0" sz="1000">
+                <a:solidFill>
+                  <a:srgbClr val="404040"/>
+                </a:solidFill>
+              </a:rPr>
+              <a:t>215–220 días. Sin ventaja clara sobre M4 con 20 evaluaciones; M10-HPO logra 212 días con 100.</a:t>
+            </a:r>
+          </a:p>
+          <a:p>
+            <a:pPr algn="l"/>
+            <a:r>
+              <a:rPr b="0" sz="600">
+                <a:solidFill>
+                  <a:srgbClr val="404040"/>
+                </a:solidFill>
+              </a:rPr>
+              <a:t> </a:t>
+            </a:r>
+          </a:p>
+        </p:txBody>
+      </p:sp>
+      <p:sp>
+        <p:nvSpPr>
+          <p:cNvPr id="6" name="Rectangle 5"/>
+          <p:cNvSpPr/>
+          <p:nvPr/>
+        </p:nvSpPr>
+        <p:spPr>
+          <a:xfrm>
+            <a:off x="7543800" y="1719072"/>
+            <a:ext cx="36576" cy="4892040"/>
+          </a:xfrm>
+          <a:prstGeom prst="rect">
+            <a:avLst/>
+          </a:prstGeom>
+          <a:solidFill>
+            <a:srgbClr val="1F497D"/>
+          </a:solidFill>
+          <a:ln>
+            <a:noFill/>
+          </a:ln>
+        </p:spPr>
+        <p:style>
+          <a:lnRef idx="1">
+            <a:schemeClr val="accent1"/>
+          </a:lnRef>
+          <a:fillRef idx="3">
+            <a:schemeClr val="accent1"/>
+          </a:fillRef>
+          <a:effectRef idx="2">
+            <a:schemeClr val="accent1"/>
+          </a:effectRef>
+          <a:fontRef idx="minor">
+            <a:schemeClr val="lt1"/>
+          </a:fontRef>
+        </p:style>
+        <p:txBody>
+          <a:bodyPr rtlCol="0" anchor="ctr"/>
+          <a:lstStyle/>
+          <a:p>
+            <a:pPr algn="ctr"/>
+          </a:p>
+        </p:txBody>
+      </p:sp>
+      <p:sp>
+        <p:nvSpPr>
+          <p:cNvPr id="7" name="TextBox 6"/>
+          <p:cNvSpPr txBox="1"/>
+          <p:nvPr/>
+        </p:nvSpPr>
+        <p:spPr>
+          <a:xfrm>
+            <a:off x="274320" y="4663440"/>
+            <a:ext cx="7223760" cy="594360"/>
+          </a:xfrm>
+          <a:prstGeom prst="rect">
+            <a:avLst/>
+          </a:prstGeom>
+          <a:noFill/>
+        </p:spPr>
+        <p:txBody>
+          <a:bodyPr wrap="square">
+            <a:spAutoFit/>
+          </a:bodyPr>
+          <a:lstStyle/>
+          <a:p>
+            <a:pPr algn="l"/>
+            <a:r>
+              <a:rPr b="0" sz="850">
+                <a:solidFill>
+                  <a:srgbClr val="808080"/>
+                </a:solidFill>
+              </a:rPr>
+              <a:t>Referencia: Ankenman, Nelson &amp; Staum (2010) — «Stochastic Kriging for Simulation Metamodeling» — Management Science
++ Scott, Powell &amp; Frazier (2011) — «The Correlated Knowledge Gradient» — SIAM J. Optimization
++ Quan, Nelson &amp; Patelis (2013) — «Simulation Optimization via REVI» — IIE Transactions</a:t>
+            </a:r>
+          </a:p>
+        </p:txBody>
+      </p:sp>
+    </p:spTree>
+  </p:cSld>
+  <p:clrMapOvr>
+    <a:masterClrMapping/>
+  </p:clrMapOvr>
+</p:sld>
+</file>
+
+<file path=ppt/slides/slide22.xml><?xml version="1.0" encoding="utf-8"?>
+<p:sld xmlns:a="http://schemas.openxmlformats.org/drawingml/2006/main" xmlns:p="http://schemas.openxmlformats.org/presentationml/2006/main" xmlns:r="http://schemas.openxmlformats.org/officeDocument/2006/relationships">
+  <p:cSld>
+    <p:bg>
+      <p:bgPr>
+        <a:solidFill>
+          <a:srgbClr val="E2F0D9"/>
+        </a:solidFill>
+        <a:effectLst/>
+      </p:bgPr>
+    </p:bg>
+    <p:spTree>
+      <p:nvGrpSpPr>
+        <p:cNvPr id="1" name=""/>
+        <p:cNvGrpSpPr/>
+        <p:nvPr/>
+      </p:nvGrpSpPr>
+      <p:grpSpPr/>
+      <p:sp>
+        <p:nvSpPr>
+          <p:cNvPr id="2" name="Rectangle 1"/>
+          <p:cNvSpPr/>
+          <p:nvPr/>
+        </p:nvSpPr>
+        <p:spPr>
+          <a:xfrm>
+            <a:off x="0" y="0"/>
+            <a:ext cx="12188952" cy="1188720"/>
+          </a:xfrm>
+          <a:prstGeom prst="rect">
+            <a:avLst/>
+          </a:prstGeom>
+          <a:solidFill>
+            <a:srgbClr val="1F497D"/>
+          </a:solidFill>
+          <a:ln>
+            <a:noFill/>
+          </a:ln>
+        </p:spPr>
+        <p:style>
+          <a:lnRef idx="1">
+            <a:schemeClr val="accent1"/>
+          </a:lnRef>
+          <a:fillRef idx="3">
+            <a:schemeClr val="accent1"/>
+          </a:fillRef>
+          <a:effectRef idx="2">
+            <a:schemeClr val="accent1"/>
+          </a:effectRef>
+          <a:fontRef idx="minor">
+            <a:schemeClr val="lt1"/>
+          </a:fontRef>
+        </p:style>
+        <p:txBody>
+          <a:bodyPr rtlCol="0" anchor="ctr" wrap="square" tIns="76200" lIns="274320"/>
+          <a:lstStyle/>
+          <a:p>
+            <a:pPr algn="l"/>
+            <a:r>
+              <a:rPr b="1" sz="2400">
+                <a:solidFill>
+                  <a:srgbClr val="FFFFFF"/>
+                </a:solidFill>
+              </a:rPr>
+              <a:t>M11 — ASTRO-DF — Adaptive Sampling Trust-Region Optimization (Derivative-Free)</a:t>
+            </a:r>
+          </a:p>
+          <a:p>
+            <a:pPr algn="l"/>
+            <a:r>
+              <a:rPr b="0" sz="1300">
+                <a:solidFill>
+                  <a:srgbClr val="BDD7EE"/>
+                </a:solidFill>
+              </a:rPr>
+              <a:t>Paper: Poloczek, Wang &amp; Frazier (2017) — «Multi-Information Source Optimization» — NeurIPS / Wint…</a:t>
+            </a:r>
+          </a:p>
+        </p:txBody>
+      </p:sp>
+      <p:sp>
+        <p:nvSpPr>
+          <p:cNvPr id="3" name="TextBox 2"/>
+          <p:cNvSpPr txBox="1"/>
+          <p:nvPr/>
+        </p:nvSpPr>
+        <p:spPr>
+          <a:xfrm>
+            <a:off x="274320" y="1261872"/>
+            <a:ext cx="11640312" cy="457200"/>
+          </a:xfrm>
+          <a:prstGeom prst="rect">
+            <a:avLst/>
+          </a:prstGeom>
+          <a:noFill/>
+        </p:spPr>
+        <p:txBody>
+          <a:bodyPr wrap="square">
+            <a:spAutoFit/>
+          </a:bodyPr>
+          <a:lstStyle/>
+          <a:p>
+            <a:pPr algn="ctr"/>
+            <a:r>
+              <a:rPr b="1" sz="1300">
+                <a:solidFill>
+                  <a:srgbClr val="1F497D"/>
+                </a:solidFill>
+              </a:rPr>
+              <a:t>Analogía: Un excursionista con niebla que explora de a pasos pequeños y seguros</a:t>
+            </a:r>
+          </a:p>
+        </p:txBody>
+      </p:sp>
+      <p:sp>
+        <p:nvSpPr>
+          <p:cNvPr id="4" name="TextBox 3"/>
+          <p:cNvSpPr txBox="1"/>
+          <p:nvPr/>
+        </p:nvSpPr>
+        <p:spPr>
+          <a:xfrm>
+            <a:off x="274320" y="1719072"/>
+            <a:ext cx="7223760" cy="2834640"/>
+          </a:xfrm>
+          <a:prstGeom prst="rect">
+            <a:avLst/>
+          </a:prstGeom>
+          <a:noFill/>
+        </p:spPr>
+        <p:txBody>
+          <a:bodyPr wrap="square">
+            <a:spAutoFit/>
+          </a:bodyPr>
+          <a:lstStyle/>
+          <a:p>
+            <a:pPr algn="l"/>
+            <a:r>
+              <a:rPr b="1" sz="1100">
+                <a:solidFill>
+                  <a:srgbClr val="1F497D"/>
+                </a:solidFill>
+              </a:rPr>
+              <a:t>¿Cómo funciona? (versión simple)</a:t>
+            </a:r>
+          </a:p>
+          <a:p>
+            <a:pPr algn="l"/>
+            <a:r>
+              <a:rPr b="0" sz="1050">
+                <a:solidFill>
+                  <a:srgbClr val="404040"/>
+                </a:solidFill>
+              </a:rPr>
+              <a:t>En lugar de un mapa global, ASTRO-DF busca localmente: está parado en un punto,
+prueba vecinos cercanos, construye una línea recta que describe la pendiente local,
+y da un paso hacia donde baja más.
+El radio del paso ('región de confianza' Δ) se agranda si la mejora fue buena
+y se achica si el modelo local fue impreciso.
+La parte 'adaptive sampling' significa que hace MUCHAS réplicas (~30) en cada punto
+para estimar bien el gradiente pese al ruido del simulador.</a:t>
+            </a:r>
+          </a:p>
+        </p:txBody>
+      </p:sp>
+      <p:sp>
+        <p:nvSpPr>
+          <p:cNvPr id="5" name="TextBox 4"/>
+          <p:cNvSpPr txBox="1"/>
+          <p:nvPr/>
+        </p:nvSpPr>
+        <p:spPr>
+          <a:xfrm>
+            <a:off x="7680960" y="1719072"/>
+            <a:ext cx="4297680" cy="4846320"/>
+          </a:xfrm>
+          <a:prstGeom prst="rect">
+            <a:avLst/>
+          </a:prstGeom>
+          <a:noFill/>
+        </p:spPr>
+        <p:txBody>
+          <a:bodyPr wrap="square">
+            <a:spAutoFit/>
+          </a:bodyPr>
+          <a:lstStyle/>
+          <a:p>
+            <a:pPr algn="l"/>
+            <a:r>
+              <a:rPr b="1" sz="1050">
+                <a:solidFill>
+                  <a:srgbClr val="1F497D"/>
+                </a:solidFill>
+              </a:rPr>
+              <a:t>¿Cuándo usar?</a:t>
+            </a:r>
+          </a:p>
+          <a:p>
+            <a:pPr algn="l"/>
+            <a:r>
+              <a:rPr b="0" sz="1000">
+                <a:solidFill>
+                  <a:srgbClr val="404040"/>
+                </a:solidFill>
+              </a:rPr>
+              <a:t>Función ruidosa con estructura local suave. Requiere presupuesto grande de simulación.</a:t>
+            </a:r>
+          </a:p>
+          <a:p>
+            <a:pPr algn="l"/>
+            <a:r>
+              <a:rPr b="0" sz="600">
+                <a:solidFill>
+                  <a:srgbClr val="404040"/>
+                </a:solidFill>
+              </a:rPr>
+              <a:t> </a:t>
+            </a:r>
+          </a:p>
+          <a:p>
+            <a:pPr algn="l"/>
+            <a:r>
+              <a:rPr b="1" sz="1050">
+                <a:solidFill>
+                  <a:srgbClr val="378648"/>
+                </a:solidFill>
+              </a:rPr>
+              <a:t>Fortaleza</a:t>
+            </a:r>
+          </a:p>
+          <a:p>
+            <a:pPr algn="l"/>
+            <a:r>
+              <a:rPr b="0" sz="1000">
+                <a:solidFill>
+                  <a:srgbClr val="404040"/>
+                </a:solidFill>
+              </a:rPr>
+              <a:t>Convergencia garantizada teóricamente bajo condiciones de ruido controlado.</a:t>
+            </a:r>
+          </a:p>
+          <a:p>
+            <a:pPr algn="l"/>
+            <a:r>
+              <a:rPr b="0" sz="600">
+                <a:solidFill>
+                  <a:srgbClr val="404040"/>
+                </a:solidFill>
+              </a:rPr>
+              <a:t> </a:t>
+            </a:r>
+          </a:p>
+          <a:p>
+            <a:pPr algn="l"/>
+            <a:r>
+              <a:rPr b="1" sz="1050">
+                <a:solidFill>
+                  <a:srgbClr val="C55A11"/>
+                </a:solidFill>
+              </a:rPr>
+              <a:t>Debilidad</a:t>
+            </a:r>
+          </a:p>
+          <a:p>
+            <a:pPr algn="l"/>
+            <a:r>
+              <a:rPr b="0" sz="1000">
+                <a:solidFill>
+                  <a:srgbClr val="404040"/>
+                </a:solidFill>
+              </a:rPr>
+              <a:t>~30 réplicas por punto → muy lento. En nube (4h) no completó ni 1 iteración.</a:t>
+            </a:r>
+          </a:p>
+          <a:p>
+            <a:pPr algn="l"/>
+            <a:r>
+              <a:rPr b="0" sz="600">
+                <a:solidFill>
+                  <a:srgbClr val="404040"/>
+                </a:solidFill>
+              </a:rPr>
+              <a:t> </a:t>
+            </a:r>
+          </a:p>
+          <a:p>
+            <a:pPr algn="l"/>
+            <a:r>
+              <a:rPr b="1" sz="1050">
+                <a:solidFill>
+                  <a:srgbClr val="404040"/>
+                </a:solidFill>
+              </a:rPr>
+              <a:t>Resultado obtenido</a:t>
+            </a:r>
+          </a:p>
+          <a:p>
+            <a:pPr algn="l"/>
+            <a:r>
+              <a:rPr b="0" sz="1000">
+                <a:solidFill>
+                  <a:srgbClr val="404040"/>
+                </a:solidFill>
+              </a:rPr>
+              <a:t>Sin datos — timeout. Cada iteración requiere ~2h en este simulador.</a:t>
+            </a:r>
+          </a:p>
+          <a:p>
+            <a:pPr algn="l"/>
+            <a:r>
+              <a:rPr b="0" sz="600">
+                <a:solidFill>
+                  <a:srgbClr val="404040"/>
+                </a:solidFill>
+              </a:rPr>
+              <a:t> </a:t>
+            </a:r>
+          </a:p>
+        </p:txBody>
+      </p:sp>
+      <p:sp>
+        <p:nvSpPr>
+          <p:cNvPr id="6" name="Rectangle 5"/>
+          <p:cNvSpPr/>
+          <p:nvPr/>
+        </p:nvSpPr>
+        <p:spPr>
+          <a:xfrm>
+            <a:off x="7543800" y="1719072"/>
+            <a:ext cx="36576" cy="4892040"/>
+          </a:xfrm>
+          <a:prstGeom prst="rect">
+            <a:avLst/>
+          </a:prstGeom>
+          <a:solidFill>
+            <a:srgbClr val="1F497D"/>
+          </a:solidFill>
+          <a:ln>
+            <a:noFill/>
+          </a:ln>
+        </p:spPr>
+        <p:style>
+          <a:lnRef idx="1">
+            <a:schemeClr val="accent1"/>
+          </a:lnRef>
+          <a:fillRef idx="3">
+            <a:schemeClr val="accent1"/>
+          </a:fillRef>
+          <a:effectRef idx="2">
+            <a:schemeClr val="accent1"/>
+          </a:effectRef>
+          <a:fontRef idx="minor">
+            <a:schemeClr val="lt1"/>
+          </a:fontRef>
+        </p:style>
+        <p:txBody>
+          <a:bodyPr rtlCol="0" anchor="ctr"/>
+          <a:lstStyle/>
+          <a:p>
+            <a:pPr algn="ctr"/>
+          </a:p>
+        </p:txBody>
+      </p:sp>
+      <p:sp>
+        <p:nvSpPr>
+          <p:cNvPr id="7" name="TextBox 6"/>
+          <p:cNvSpPr txBox="1"/>
+          <p:nvPr/>
+        </p:nvSpPr>
+        <p:spPr>
+          <a:xfrm>
+            <a:off x="274320" y="4663440"/>
+            <a:ext cx="7223760" cy="594360"/>
+          </a:xfrm>
+          <a:prstGeom prst="rect">
+            <a:avLst/>
+          </a:prstGeom>
+          <a:noFill/>
+        </p:spPr>
+        <p:txBody>
+          <a:bodyPr wrap="square">
+            <a:spAutoFit/>
+          </a:bodyPr>
+          <a:lstStyle/>
+          <a:p>
+            <a:pPr algn="l"/>
+            <a:r>
+              <a:rPr b="0" sz="850">
+                <a:solidFill>
+                  <a:srgbClr val="808080"/>
+                </a:solidFill>
+              </a:rPr>
+              <a:t>Referencia: Poloczek, Wang &amp; Frazier (2017) — «Multi-Information Source Optimization» — NeurIPS / Winter Simulation Conference</a:t>
+            </a:r>
+          </a:p>
+        </p:txBody>
+      </p:sp>
+    </p:spTree>
+  </p:cSld>
+  <p:clrMapOvr>
+    <a:masterClrMapping/>
+  </p:clrMapOvr>
+</p:sld>
+</file>
+
+<file path=ppt/slides/slide23.xml><?xml version="1.0" encoding="utf-8"?>
+<p:sld xmlns:a="http://schemas.openxmlformats.org/drawingml/2006/main" xmlns:p="http://schemas.openxmlformats.org/presentationml/2006/main" xmlns:r="http://schemas.openxmlformats.org/officeDocument/2006/relationships">
+  <p:cSld>
+    <p:bg>
+      <p:bgPr>
+        <a:solidFill>
+          <a:srgbClr val="D5EBCB"/>
+        </a:solidFill>
+        <a:effectLst/>
+      </p:bgPr>
+    </p:bg>
+    <p:spTree>
+      <p:nvGrpSpPr>
+        <p:cNvPr id="1" name=""/>
+        <p:cNvGrpSpPr/>
+        <p:nvPr/>
+      </p:nvGrpSpPr>
+      <p:grpSpPr/>
+      <p:sp>
+        <p:nvSpPr>
+          <p:cNvPr id="2" name="Rectangle 1"/>
+          <p:cNvSpPr/>
+          <p:nvPr/>
+        </p:nvSpPr>
+        <p:spPr>
+          <a:xfrm>
+            <a:off x="0" y="0"/>
+            <a:ext cx="12188952" cy="1188720"/>
+          </a:xfrm>
+          <a:prstGeom prst="rect">
+            <a:avLst/>
+          </a:prstGeom>
+          <a:solidFill>
+            <a:srgbClr val="1F497D"/>
+          </a:solidFill>
+          <a:ln>
+            <a:noFill/>
+          </a:ln>
+        </p:spPr>
+        <p:style>
+          <a:lnRef idx="1">
+            <a:schemeClr val="accent1"/>
+          </a:lnRef>
+          <a:fillRef idx="3">
+            <a:schemeClr val="accent1"/>
+          </a:fillRef>
+          <a:effectRef idx="2">
+            <a:schemeClr val="accent1"/>
+          </a:effectRef>
+          <a:fontRef idx="minor">
+            <a:schemeClr val="lt1"/>
+          </a:fontRef>
+        </p:style>
+        <p:txBody>
+          <a:bodyPr rtlCol="0" anchor="ctr" wrap="square" tIns="76200" lIns="274320"/>
+          <a:lstStyle/>
+          <a:p>
+            <a:pPr algn="l"/>
+            <a:r>
+              <a:rPr b="1" sz="2400">
+                <a:solidFill>
+                  <a:srgbClr val="FFFFFF"/>
+                </a:solidFill>
+              </a:rPr>
+              <a:t>M12 — STRONG — Stochastic Trust-Region Response-surface with Optimal Regression and Nonnegative constraint</a:t>
+            </a:r>
+          </a:p>
+          <a:p>
+            <a:pPr algn="l"/>
+            <a:r>
+              <a:rPr b="0" sz="1300">
+                <a:solidFill>
+                  <a:srgbClr val="BDD7EE"/>
+                </a:solidFill>
+              </a:rPr>
+              <a:t>Paper: Chang, Hong &amp; Wan (2013) — «Stochastic Trust-Region Response-Surface Method (STRONG)» — AC…</a:t>
+            </a:r>
+          </a:p>
+        </p:txBody>
+      </p:sp>
+      <p:sp>
+        <p:nvSpPr>
+          <p:cNvPr id="3" name="TextBox 2"/>
+          <p:cNvSpPr txBox="1"/>
+          <p:nvPr/>
+        </p:nvSpPr>
+        <p:spPr>
+          <a:xfrm>
+            <a:off x="274320" y="1261872"/>
+            <a:ext cx="11640312" cy="457200"/>
+          </a:xfrm>
+          <a:prstGeom prst="rect">
+            <a:avLst/>
+          </a:prstGeom>
+          <a:noFill/>
+        </p:spPr>
+        <p:txBody>
+          <a:bodyPr wrap="square">
+            <a:spAutoFit/>
+          </a:bodyPr>
+          <a:lstStyle/>
+          <a:p>
+            <a:pPr algn="ctr"/>
+            <a:r>
+              <a:rPr b="1" sz="1300">
+                <a:solidFill>
+                  <a:srgbClr val="1F497D"/>
+                </a:solidFill>
+              </a:rPr>
+              <a:t>Analogía: Un excursionista que en lugar de una línea recta usa un mapa curvado del terreno cercano</a:t>
+            </a:r>
+          </a:p>
+        </p:txBody>
+      </p:sp>
+      <p:sp>
+        <p:nvSpPr>
+          <p:cNvPr id="4" name="TextBox 3"/>
+          <p:cNvSpPr txBox="1"/>
+          <p:nvPr/>
+        </p:nvSpPr>
+        <p:spPr>
+          <a:xfrm>
+            <a:off x="274320" y="1719072"/>
+            <a:ext cx="7223760" cy="2834640"/>
+          </a:xfrm>
+          <a:prstGeom prst="rect">
+            <a:avLst/>
+          </a:prstGeom>
+          <a:noFill/>
+        </p:spPr>
+        <p:txBody>
+          <a:bodyPr wrap="square">
+            <a:spAutoFit/>
+          </a:bodyPr>
+          <a:lstStyle/>
+          <a:p>
+            <a:pPr algn="l"/>
+            <a:r>
+              <a:rPr b="1" sz="1100">
+                <a:solidFill>
+                  <a:srgbClr val="1F497D"/>
+                </a:solidFill>
+              </a:rPr>
+              <a:t>¿Cómo funciona? (versión simple)</a:t>
+            </a:r>
+          </a:p>
+          <a:p>
+            <a:pPr algn="l"/>
+            <a:r>
+              <a:rPr b="0" sz="1050">
+                <a:solidFill>
+                  <a:srgbClr val="404040"/>
+                </a:solidFill>
+              </a:rPr>
+              <a:t>Similar a ASTRO-DF pero más sofisticado: en vez de ajustar una línea recta local,
+ajusta una parábola (modelo cuadrático) con los puntos del vecindario.
+Esto permite detectar valles curvos (no solo planos inclinados), pero necesita
+evaluar MUCHOS más puntos para construir ese modelo:
+n0=10 puntos iniciales × n_r=10 réplicas = 100 evaluaciones solo para arrancar.
+La región de confianza Δ se ajusta igual que en ASTRO-DF.</a:t>
+            </a:r>
+          </a:p>
+        </p:txBody>
+      </p:sp>
+      <p:sp>
+        <p:nvSpPr>
+          <p:cNvPr id="5" name="TextBox 4"/>
+          <p:cNvSpPr txBox="1"/>
+          <p:nvPr/>
+        </p:nvSpPr>
+        <p:spPr>
+          <a:xfrm>
+            <a:off x="7680960" y="1719072"/>
+            <a:ext cx="4297680" cy="4846320"/>
+          </a:xfrm>
+          <a:prstGeom prst="rect">
+            <a:avLst/>
+          </a:prstGeom>
+          <a:noFill/>
+        </p:spPr>
+        <p:txBody>
+          <a:bodyPr wrap="square">
+            <a:spAutoFit/>
+          </a:bodyPr>
+          <a:lstStyle/>
+          <a:p>
+            <a:pPr algn="l"/>
+            <a:r>
+              <a:rPr b="1" sz="1050">
+                <a:solidFill>
+                  <a:srgbClr val="1F497D"/>
+                </a:solidFill>
+              </a:rPr>
+              <a:t>¿Cuándo usar?</a:t>
+            </a:r>
+          </a:p>
+          <a:p>
+            <a:pPr algn="l"/>
+            <a:r>
+              <a:rPr b="0" sz="1000">
+                <a:solidFill>
+                  <a:srgbClr val="404040"/>
+                </a:solidFill>
+              </a:rPr>
+              <a:t>Espacios con curvatura local importante y presupuesto muy alto de simulación (&gt;500 eval).</a:t>
+            </a:r>
+          </a:p>
+          <a:p>
+            <a:pPr algn="l"/>
+            <a:r>
+              <a:rPr b="0" sz="600">
+                <a:solidFill>
+                  <a:srgbClr val="404040"/>
+                </a:solidFill>
+              </a:rPr>
+              <a:t> </a:t>
+            </a:r>
+          </a:p>
+          <a:p>
+            <a:pPr algn="l"/>
+            <a:r>
+              <a:rPr b="1" sz="1050">
+                <a:solidFill>
+                  <a:srgbClr val="378648"/>
+                </a:solidFill>
+              </a:rPr>
+              <a:t>Fortaleza</a:t>
+            </a:r>
+          </a:p>
+          <a:p>
+            <a:pPr algn="l"/>
+            <a:r>
+              <a:rPr b="0" sz="1000">
+                <a:solidFill>
+                  <a:srgbClr val="404040"/>
+                </a:solidFill>
+              </a:rPr>
+              <a:t>Modelo local más preciso que ASTRO-DF → mejor dirección de búsqueda en cada paso.</a:t>
+            </a:r>
+          </a:p>
+          <a:p>
+            <a:pPr algn="l"/>
+            <a:r>
+              <a:rPr b="0" sz="600">
+                <a:solidFill>
+                  <a:srgbClr val="404040"/>
+                </a:solidFill>
+              </a:rPr>
+              <a:t> </a:t>
+            </a:r>
+          </a:p>
+          <a:p>
+            <a:pPr algn="l"/>
+            <a:r>
+              <a:rPr b="1" sz="1050">
+                <a:solidFill>
+                  <a:srgbClr val="C55A11"/>
+                </a:solidFill>
+              </a:rPr>
+              <a:t>Debilidad</a:t>
+            </a:r>
+          </a:p>
+          <a:p>
+            <a:pPr algn="l"/>
+            <a:r>
+              <a:rPr b="0" sz="1000">
+                <a:solidFill>
+                  <a:srgbClr val="404040"/>
+                </a:solidFill>
+              </a:rPr>
+              <a:t>x0 requirió &gt;2h solo para 100 evaluaciones iniciales. El más lento de todos.</a:t>
+            </a:r>
+          </a:p>
+          <a:p>
+            <a:pPr algn="l"/>
+            <a:r>
+              <a:rPr b="0" sz="600">
+                <a:solidFill>
+                  <a:srgbClr val="404040"/>
+                </a:solidFill>
+              </a:rPr>
+              <a:t> </a:t>
+            </a:r>
+          </a:p>
+          <a:p>
+            <a:pPr algn="l"/>
+            <a:r>
+              <a:rPr b="1" sz="1050">
+                <a:solidFill>
+                  <a:srgbClr val="404040"/>
+                </a:solidFill>
+              </a:rPr>
+              <a:t>Resultado obtenido</a:t>
+            </a:r>
+          </a:p>
+          <a:p>
+            <a:pPr algn="l"/>
+            <a:r>
+              <a:rPr b="0" sz="1000">
+                <a:solidFill>
+                  <a:srgbClr val="404040"/>
+                </a:solidFill>
+              </a:rPr>
+              <a:t>Sin datos — timeout. El simulador DES es demasiado lento para este algoritmo.</a:t>
+            </a:r>
+          </a:p>
+          <a:p>
+            <a:pPr algn="l"/>
+            <a:r>
+              <a:rPr b="0" sz="600">
+                <a:solidFill>
+                  <a:srgbClr val="404040"/>
+                </a:solidFill>
+              </a:rPr>
+              <a:t> </a:t>
+            </a:r>
+          </a:p>
+        </p:txBody>
+      </p:sp>
+      <p:sp>
+        <p:nvSpPr>
+          <p:cNvPr id="6" name="Rectangle 5"/>
+          <p:cNvSpPr/>
+          <p:nvPr/>
+        </p:nvSpPr>
+        <p:spPr>
+          <a:xfrm>
+            <a:off x="7543800" y="1719072"/>
+            <a:ext cx="36576" cy="4892040"/>
+          </a:xfrm>
+          <a:prstGeom prst="rect">
+            <a:avLst/>
+          </a:prstGeom>
+          <a:solidFill>
+            <a:srgbClr val="1F497D"/>
+          </a:solidFill>
+          <a:ln>
+            <a:noFill/>
+          </a:ln>
+        </p:spPr>
+        <p:style>
+          <a:lnRef idx="1">
+            <a:schemeClr val="accent1"/>
+          </a:lnRef>
+          <a:fillRef idx="3">
+            <a:schemeClr val="accent1"/>
+          </a:fillRef>
+          <a:effectRef idx="2">
+            <a:schemeClr val="accent1"/>
+          </a:effectRef>
+          <a:fontRef idx="minor">
+            <a:schemeClr val="lt1"/>
+          </a:fontRef>
+        </p:style>
+        <p:txBody>
+          <a:bodyPr rtlCol="0" anchor="ctr"/>
+          <a:lstStyle/>
+          <a:p>
+            <a:pPr algn="ctr"/>
+          </a:p>
+        </p:txBody>
+      </p:sp>
+      <p:sp>
+        <p:nvSpPr>
+          <p:cNvPr id="7" name="TextBox 6"/>
+          <p:cNvSpPr txBox="1"/>
+          <p:nvPr/>
+        </p:nvSpPr>
+        <p:spPr>
+          <a:xfrm>
+            <a:off x="274320" y="4663440"/>
+            <a:ext cx="7223760" cy="594360"/>
+          </a:xfrm>
+          <a:prstGeom prst="rect">
+            <a:avLst/>
+          </a:prstGeom>
+          <a:noFill/>
+        </p:spPr>
+        <p:txBody>
+          <a:bodyPr wrap="square">
+            <a:spAutoFit/>
+          </a:bodyPr>
+          <a:lstStyle/>
+          <a:p>
+            <a:pPr algn="l"/>
+            <a:r>
+              <a:rPr b="0" sz="850">
+                <a:solidFill>
+                  <a:srgbClr val="808080"/>
+                </a:solidFill>
+              </a:rPr>
+              <a:t>Referencia: Chang, Hong &amp; Wan (2013) — «Stochastic Trust-Region Response-Surface Method (STRONG)» — ACM TOMACS</a:t>
+            </a:r>
+          </a:p>
+        </p:txBody>
+      </p:sp>
+    </p:spTree>
+  </p:cSld>
+  <p:clrMapOvr>
+    <a:masterClrMapping/>
+  </p:clrMapOvr>
+</p:sld>
+</file>
+
+<file path=ppt/slides/slide24.xml><?xml version="1.0" encoding="utf-8"?>
+<p:sld xmlns:a="http://schemas.openxmlformats.org/drawingml/2006/main" xmlns:p="http://schemas.openxmlformats.org/presentationml/2006/main" xmlns:r="http://schemas.openxmlformats.org/officeDocument/2006/relationships">
+  <p:cSld>
+    <p:bg>
+      <p:bgPr>
+        <a:solidFill>
+          <a:srgbClr val="FDF0D0"/>
+        </a:solidFill>
+        <a:effectLst/>
+      </p:bgPr>
+    </p:bg>
+    <p:spTree>
+      <p:nvGrpSpPr>
+        <p:cNvPr id="1" name=""/>
+        <p:cNvGrpSpPr/>
+        <p:nvPr/>
+      </p:nvGrpSpPr>
+      <p:grpSpPr/>
+      <p:sp>
+        <p:nvSpPr>
+          <p:cNvPr id="2" name="Rectangle 1"/>
+          <p:cNvSpPr/>
+          <p:nvPr/>
+        </p:nvSpPr>
+        <p:spPr>
+          <a:xfrm>
+            <a:off x="0" y="0"/>
+            <a:ext cx="12188952" cy="1188720"/>
+          </a:xfrm>
+          <a:prstGeom prst="rect">
+            <a:avLst/>
+          </a:prstGeom>
+          <a:solidFill>
+            <a:srgbClr val="1F497D"/>
+          </a:solidFill>
+          <a:ln>
+            <a:noFill/>
+          </a:ln>
+        </p:spPr>
+        <p:style>
+          <a:lnRef idx="1">
+            <a:schemeClr val="accent1"/>
+          </a:lnRef>
+          <a:fillRef idx="3">
+            <a:schemeClr val="accent1"/>
+          </a:fillRef>
+          <a:effectRef idx="2">
+            <a:schemeClr val="accent1"/>
+          </a:effectRef>
+          <a:fontRef idx="minor">
+            <a:schemeClr val="lt1"/>
+          </a:fontRef>
+        </p:style>
+        <p:txBody>
+          <a:bodyPr rtlCol="0" anchor="ctr" wrap="square" tIns="76200" lIns="274320"/>
+          <a:lstStyle/>
+          <a:p>
+            <a:pPr algn="l"/>
+            <a:r>
+              <a:rPr b="1" sz="2400">
+                <a:solidFill>
+                  <a:srgbClr val="FFFFFF"/>
+                </a:solidFill>
+              </a:rPr>
+              <a:t>M13 — SPSA — Simultaneous Perturbation Stochastic Approximation</a:t>
+            </a:r>
+          </a:p>
+          <a:p>
+            <a:pPr algn="l"/>
+            <a:r>
+              <a:rPr b="0" sz="1300">
+                <a:solidFill>
+                  <a:srgbClr val="BDD7EE"/>
+                </a:solidFill>
+              </a:rPr>
+              <a:t>Paper: Spall (1992) — «Multivariate Stochastic Approximation Using a Simultaneous Perturbation Gr…</a:t>
+            </a:r>
+          </a:p>
+        </p:txBody>
+      </p:sp>
+      <p:sp>
+        <p:nvSpPr>
+          <p:cNvPr id="3" name="TextBox 2"/>
+          <p:cNvSpPr txBox="1"/>
+          <p:nvPr/>
+        </p:nvSpPr>
+        <p:spPr>
+          <a:xfrm>
+            <a:off x="274320" y="1261872"/>
+            <a:ext cx="11640312" cy="457200"/>
+          </a:xfrm>
+          <a:prstGeom prst="rect">
+            <a:avLst/>
+          </a:prstGeom>
+          <a:noFill/>
+        </p:spPr>
+        <p:txBody>
+          <a:bodyPr wrap="square">
+            <a:spAutoFit/>
+          </a:bodyPr>
+          <a:lstStyle/>
+          <a:p>
+            <a:pPr algn="ctr"/>
+            <a:r>
+              <a:rPr b="1" sz="1300">
+                <a:solidFill>
+                  <a:srgbClr val="1F497D"/>
+                </a:solidFill>
+              </a:rPr>
+              <a:t>Analogía: Un chef que prueba una versión picante y otra sosa del plato para saber si ajustar la sal</a:t>
+            </a:r>
+          </a:p>
+        </p:txBody>
+      </p:sp>
+      <p:sp>
+        <p:nvSpPr>
+          <p:cNvPr id="4" name="TextBox 3"/>
+          <p:cNvSpPr txBox="1"/>
+          <p:nvPr/>
+        </p:nvSpPr>
+        <p:spPr>
+          <a:xfrm>
+            <a:off x="274320" y="1719072"/>
+            <a:ext cx="7223760" cy="2834640"/>
+          </a:xfrm>
+          <a:prstGeom prst="rect">
+            <a:avLst/>
+          </a:prstGeom>
+          <a:noFill/>
+        </p:spPr>
+        <p:txBody>
+          <a:bodyPr wrap="square">
+            <a:spAutoFit/>
+          </a:bodyPr>
+          <a:lstStyle/>
+          <a:p>
+            <a:pPr algn="l"/>
+            <a:r>
+              <a:rPr b="1" sz="1100">
+                <a:solidFill>
+                  <a:srgbClr val="1F497D"/>
+                </a:solidFill>
+              </a:rPr>
+              <a:t>¿Cómo funciona? (versión simple)</a:t>
+            </a:r>
+          </a:p>
+          <a:p>
+            <a:pPr algn="l"/>
+            <a:r>
+              <a:rPr b="0" sz="1050">
+                <a:solidFill>
+                  <a:srgbClr val="404040"/>
+                </a:solidFill>
+              </a:rPr>
+              <a:t>Para saber en qué dirección mejorar, el algoritmo perturba TODAS las variables
+simultáneamente con signos aleatorios (+/-) y hace 2 evaluaciones:
+  x+ = x + c·δ    →  f(x+)
+  x- = x - c·δ    →  f(x-)
+La diferencia f(x+) - f(x-) dividida por 2·c·δ estima el gradiente completo
+con solo 2 evaluaciones sin importar cuántas variables haya.
+Luego da un paso en esa dirección: x_nuevo = x - a·gradiente_estimado.</a:t>
+            </a:r>
+          </a:p>
+        </p:txBody>
+      </p:sp>
+      <p:sp>
+        <p:nvSpPr>
+          <p:cNvPr id="5" name="TextBox 4"/>
+          <p:cNvSpPr txBox="1"/>
+          <p:nvPr/>
+        </p:nvSpPr>
+        <p:spPr>
+          <a:xfrm>
+            <a:off x="7680960" y="1719072"/>
+            <a:ext cx="4297680" cy="4846320"/>
+          </a:xfrm>
+          <a:prstGeom prst="rect">
+            <a:avLst/>
+          </a:prstGeom>
+          <a:noFill/>
+        </p:spPr>
+        <p:txBody>
+          <a:bodyPr wrap="square">
+            <a:spAutoFit/>
+          </a:bodyPr>
+          <a:lstStyle/>
+          <a:p>
+            <a:pPr algn="l"/>
+            <a:r>
+              <a:rPr b="1" sz="1050">
+                <a:solidFill>
+                  <a:srgbClr val="1F497D"/>
+                </a:solidFill>
+              </a:rPr>
+              <a:t>¿Cuándo usar?</a:t>
+            </a:r>
+          </a:p>
+          <a:p>
+            <a:pPr algn="l"/>
+            <a:r>
+              <a:rPr b="0" sz="1000">
+                <a:solidFill>
+                  <a:srgbClr val="404040"/>
+                </a:solidFill>
+              </a:rPr>
+              <a:t>Muchas variables, presupuesto moderado, función ruidosa donde no se puede calcular gradiente exacto.</a:t>
+            </a:r>
+          </a:p>
+          <a:p>
+            <a:pPr algn="l"/>
+            <a:r>
+              <a:rPr b="0" sz="600">
+                <a:solidFill>
+                  <a:srgbClr val="404040"/>
+                </a:solidFill>
+              </a:rPr>
+              <a:t> </a:t>
+            </a:r>
+          </a:p>
+          <a:p>
+            <a:pPr algn="l"/>
+            <a:r>
+              <a:rPr b="1" sz="1050">
+                <a:solidFill>
+                  <a:srgbClr val="378648"/>
+                </a:solidFill>
+              </a:rPr>
+              <a:t>Fortaleza</a:t>
+            </a:r>
+          </a:p>
+          <a:p>
+            <a:pPr algn="l"/>
+            <a:r>
+              <a:rPr b="0" sz="1000">
+                <a:solidFill>
+                  <a:srgbClr val="404040"/>
+                </a:solidFill>
+              </a:rPr>
+              <a:t>Solo 2 evaluaciones por iteración independiente del número de variables. Simple y robusto.</a:t>
+            </a:r>
+          </a:p>
+          <a:p>
+            <a:pPr algn="l"/>
+            <a:r>
+              <a:rPr b="0" sz="600">
+                <a:solidFill>
+                  <a:srgbClr val="404040"/>
+                </a:solidFill>
+              </a:rPr>
+              <a:t> </a:t>
+            </a:r>
+          </a:p>
+          <a:p>
+            <a:pPr algn="l"/>
+            <a:r>
+              <a:rPr b="1" sz="1050">
+                <a:solidFill>
+                  <a:srgbClr val="C55A11"/>
+                </a:solidFill>
+              </a:rPr>
+              <a:t>Debilidad</a:t>
+            </a:r>
+          </a:p>
+          <a:p>
+            <a:pPr algn="l"/>
+            <a:r>
+              <a:rPr b="0" sz="1000">
+                <a:solidFill>
+                  <a:srgbClr val="404040"/>
+                </a:solidFill>
+              </a:rPr>
+              <a:t>Alta varianza entre iteraciones (evaluaciones muy ruidosas). Converge lento.</a:t>
+            </a:r>
+          </a:p>
+          <a:p>
+            <a:pPr algn="l"/>
+            <a:r>
+              <a:rPr b="0" sz="600">
+                <a:solidFill>
+                  <a:srgbClr val="404040"/>
+                </a:solidFill>
+              </a:rPr>
+              <a:t> </a:t>
+            </a:r>
+          </a:p>
+          <a:p>
+            <a:pPr algn="l"/>
+            <a:r>
+              <a:rPr b="1" sz="1050">
+                <a:solidFill>
+                  <a:srgbClr val="404040"/>
+                </a:solidFill>
+              </a:rPr>
+              <a:t>Resultado obtenido</a:t>
+            </a:r>
+          </a:p>
+          <a:p>
+            <a:pPr algn="l"/>
+            <a:r>
+              <a:rPr b="0" sz="1000">
+                <a:solidFill>
+                  <a:srgbClr val="404040"/>
+                </a:solidFill>
+              </a:rPr>
+              <a:t>219.38 días en 30 iteraciones (8.65h). Mejora real encontrada en iter 1, 10 y 21.</a:t>
+            </a:r>
+          </a:p>
+          <a:p>
+            <a:pPr algn="l"/>
+            <a:r>
+              <a:rPr b="0" sz="600">
+                <a:solidFill>
+                  <a:srgbClr val="404040"/>
+                </a:solidFill>
+              </a:rPr>
+              <a:t> </a:t>
+            </a:r>
+          </a:p>
+        </p:txBody>
+      </p:sp>
+      <p:sp>
+        <p:nvSpPr>
+          <p:cNvPr id="6" name="Rectangle 5"/>
+          <p:cNvSpPr/>
+          <p:nvPr/>
+        </p:nvSpPr>
+        <p:spPr>
+          <a:xfrm>
+            <a:off x="7543800" y="1719072"/>
+            <a:ext cx="36576" cy="4892040"/>
+          </a:xfrm>
+          <a:prstGeom prst="rect">
+            <a:avLst/>
+          </a:prstGeom>
+          <a:solidFill>
+            <a:srgbClr val="1F497D"/>
+          </a:solidFill>
+          <a:ln>
+            <a:noFill/>
+          </a:ln>
+        </p:spPr>
+        <p:style>
+          <a:lnRef idx="1">
+            <a:schemeClr val="accent1"/>
+          </a:lnRef>
+          <a:fillRef idx="3">
+            <a:schemeClr val="accent1"/>
+          </a:fillRef>
+          <a:effectRef idx="2">
+            <a:schemeClr val="accent1"/>
+          </a:effectRef>
+          <a:fontRef idx="minor">
+            <a:schemeClr val="lt1"/>
+          </a:fontRef>
+        </p:style>
+        <p:txBody>
+          <a:bodyPr rtlCol="0" anchor="ctr"/>
+          <a:lstStyle/>
+          <a:p>
+            <a:pPr algn="ctr"/>
+          </a:p>
+        </p:txBody>
+      </p:sp>
+      <p:sp>
+        <p:nvSpPr>
+          <p:cNvPr id="7" name="TextBox 6"/>
+          <p:cNvSpPr txBox="1"/>
+          <p:nvPr/>
+        </p:nvSpPr>
+        <p:spPr>
+          <a:xfrm>
+            <a:off x="274320" y="4663440"/>
+            <a:ext cx="7223760" cy="594360"/>
+          </a:xfrm>
+          <a:prstGeom prst="rect">
+            <a:avLst/>
+          </a:prstGeom>
+          <a:noFill/>
+        </p:spPr>
+        <p:txBody>
+          <a:bodyPr wrap="square">
+            <a:spAutoFit/>
+          </a:bodyPr>
+          <a:lstStyle/>
+          <a:p>
+            <a:pPr algn="l"/>
+            <a:r>
+              <a:rPr b="0" sz="850">
+                <a:solidFill>
+                  <a:srgbClr val="808080"/>
+                </a:solidFill>
+              </a:rPr>
+              <a:t>Referencia: Spall (1992) — «Multivariate Stochastic Approximation Using a Simultaneous Perturbation Gradient Approximation» — IEEE Transactions on Automatic Control</a:t>
+            </a:r>
+          </a:p>
+        </p:txBody>
+      </p:sp>
+    </p:spTree>
+  </p:cSld>
+  <p:clrMapOvr>
+    <a:masterClrMapping/>
+  </p:clrMapOvr>
+</p:sld>
+</file>
+
+<file path=ppt/slides/slide25.xml><?xml version="1.0" encoding="utf-8"?>
+<p:sld xmlns:a="http://schemas.openxmlformats.org/drawingml/2006/main" xmlns:p="http://schemas.openxmlformats.org/presentationml/2006/main" xmlns:r="http://schemas.openxmlformats.org/officeDocument/2006/relationships">
+  <p:cSld>
+    <p:bg>
+      <p:bgPr>
+        <a:solidFill>
+          <a:srgbClr val="FDE8D0"/>
+        </a:solidFill>
+        <a:effectLst/>
+      </p:bgPr>
+    </p:bg>
+    <p:spTree>
+      <p:nvGrpSpPr>
+        <p:cNvPr id="1" name=""/>
+        <p:cNvGrpSpPr/>
+        <p:nvPr/>
+      </p:nvGrpSpPr>
+      <p:grpSpPr/>
+      <p:sp>
+        <p:nvSpPr>
+          <p:cNvPr id="2" name="Rectangle 1"/>
+          <p:cNvSpPr/>
+          <p:nvPr/>
+        </p:nvSpPr>
+        <p:spPr>
+          <a:xfrm>
+            <a:off x="0" y="0"/>
+            <a:ext cx="12188952" cy="1188720"/>
+          </a:xfrm>
+          <a:prstGeom prst="rect">
+            <a:avLst/>
+          </a:prstGeom>
+          <a:solidFill>
+            <a:srgbClr val="1F497D"/>
+          </a:solidFill>
+          <a:ln>
+            <a:noFill/>
+          </a:ln>
+        </p:spPr>
+        <p:style>
+          <a:lnRef idx="1">
+            <a:schemeClr val="accent1"/>
+          </a:lnRef>
+          <a:fillRef idx="3">
+            <a:schemeClr val="accent1"/>
+          </a:fillRef>
+          <a:effectRef idx="2">
+            <a:schemeClr val="accent1"/>
+          </a:effectRef>
+          <a:fontRef idx="minor">
+            <a:schemeClr val="lt1"/>
+          </a:fontRef>
+        </p:style>
+        <p:txBody>
+          <a:bodyPr rtlCol="0" anchor="ctr" wrap="square" tIns="76200" lIns="274320"/>
+          <a:lstStyle/>
+          <a:p>
+            <a:pPr algn="l"/>
+            <a:r>
+              <a:rPr b="1" sz="2400">
+                <a:solidFill>
+                  <a:srgbClr val="FFFFFF"/>
+                </a:solidFill>
+              </a:rPr>
+              <a:t>M14 — ALOE — Adaptive Line-search and Oracle-free Estimation</a:t>
+            </a:r>
+          </a:p>
+          <a:p>
+            <a:pPr algn="l"/>
+            <a:r>
+              <a:rPr b="0" sz="1300">
+                <a:solidFill>
+                  <a:srgbClr val="BDD7EE"/>
+                </a:solidFill>
+              </a:rPr>
+              <a:t>Paper: Rojas-Gonzalez &amp; Van Nieuwenhuyse (2020) — «A Survey on Kriging-Based Infill Algorithms fo…</a:t>
+            </a:r>
+          </a:p>
+        </p:txBody>
+      </p:sp>
+      <p:sp>
+        <p:nvSpPr>
+          <p:cNvPr id="3" name="TextBox 2"/>
+          <p:cNvSpPr txBox="1"/>
+          <p:nvPr/>
+        </p:nvSpPr>
+        <p:spPr>
+          <a:xfrm>
+            <a:off x="274320" y="1261872"/>
+            <a:ext cx="11640312" cy="457200"/>
+          </a:xfrm>
+          <a:prstGeom prst="rect">
+            <a:avLst/>
+          </a:prstGeom>
+          <a:noFill/>
+        </p:spPr>
+        <p:txBody>
+          <a:bodyPr wrap="square">
+            <a:spAutoFit/>
+          </a:bodyPr>
+          <a:lstStyle/>
+          <a:p>
+            <a:pPr algn="ctr"/>
+            <a:r>
+              <a:rPr b="1" sz="1300">
+                <a:solidFill>
+                  <a:srgbClr val="1F497D"/>
+                </a:solidFill>
+              </a:rPr>
+              <a:t>Analogía: Un chef que solo acepta una nueva receta si está SEGURO de que es mejor — y con ruido, nunca está seguro</a:t>
+            </a:r>
+          </a:p>
+        </p:txBody>
+      </p:sp>
+      <p:sp>
+        <p:nvSpPr>
+          <p:cNvPr id="4" name="TextBox 3"/>
+          <p:cNvSpPr txBox="1"/>
+          <p:nvPr/>
+        </p:nvSpPr>
+        <p:spPr>
+          <a:xfrm>
+            <a:off x="274320" y="1719072"/>
+            <a:ext cx="7223760" cy="2834640"/>
+          </a:xfrm>
+          <a:prstGeom prst="rect">
+            <a:avLst/>
+          </a:prstGeom>
+          <a:noFill/>
+        </p:spPr>
+        <p:txBody>
+          <a:bodyPr wrap="square">
+            <a:spAutoFit/>
+          </a:bodyPr>
+          <a:lstStyle/>
+          <a:p>
+            <a:pPr algn="l"/>
+            <a:r>
+              <a:rPr b="1" sz="1100">
+                <a:solidFill>
+                  <a:srgbClr val="1F497D"/>
+                </a:solidFill>
+              </a:rPr>
+              <a:t>¿Cómo funciona? (versión simple)</a:t>
+            </a:r>
+          </a:p>
+          <a:p>
+            <a:pPr algn="l"/>
+            <a:r>
+              <a:rPr b="0" sz="1050">
+                <a:solidFill>
+                  <a:srgbClr val="404040"/>
+                </a:solidFill>
+              </a:rPr>
+              <a:t>ALOE también estima el gradiente como SPSA pero usa 2d evaluaciones (una por variable)
+para tener una estimación más precisa. La diferencia clave es la búsqueda de Armijo:
+Antes de aceptar el paso, verifica: ¿f(nuevo) &lt; f(actual) - umbral?
+Si el simulador es ruidoso, f(nuevo) y f(actual) fluctúan tanto que la condición
+NUNCA se cumple → el paso se rechaza → el algoritmo no avanza.
+Esto pasó exactamente: en las 30 iteraciones, Armijo rechazó el 100% de los pasos.
+El algoritmo quedó paralizado en el punto inicial durante 69.5 horas.</a:t>
+            </a:r>
+          </a:p>
+        </p:txBody>
+      </p:sp>
+      <p:sp>
+        <p:nvSpPr>
+          <p:cNvPr id="5" name="TextBox 4"/>
+          <p:cNvSpPr txBox="1"/>
+          <p:nvPr/>
+        </p:nvSpPr>
+        <p:spPr>
+          <a:xfrm>
+            <a:off x="7680960" y="1719072"/>
+            <a:ext cx="4297680" cy="4846320"/>
+          </a:xfrm>
+          <a:prstGeom prst="rect">
+            <a:avLst/>
+          </a:prstGeom>
+          <a:noFill/>
+        </p:spPr>
+        <p:txBody>
+          <a:bodyPr wrap="square">
+            <a:spAutoFit/>
+          </a:bodyPr>
+          <a:lstStyle/>
+          <a:p>
+            <a:pPr algn="l"/>
+            <a:r>
+              <a:rPr b="1" sz="1050">
+                <a:solidFill>
+                  <a:srgbClr val="1F497D"/>
+                </a:solidFill>
+              </a:rPr>
+              <a:t>¿Cuándo usar?</a:t>
+            </a:r>
+          </a:p>
+          <a:p>
+            <a:pPr algn="l"/>
+            <a:r>
+              <a:rPr b="0" sz="1000">
+                <a:solidFill>
+                  <a:srgbClr val="404040"/>
+                </a:solidFill>
+              </a:rPr>
+              <a:t>Funciones deterministas o con ruido muy bajo (σ &lt; 5%). NO apto para simuladores DES.</a:t>
+            </a:r>
+          </a:p>
+          <a:p>
+            <a:pPr algn="l"/>
+            <a:r>
+              <a:rPr b="0" sz="600">
+                <a:solidFill>
+                  <a:srgbClr val="404040"/>
+                </a:solidFill>
+              </a:rPr>
+              <a:t> </a:t>
+            </a:r>
+          </a:p>
+          <a:p>
+            <a:pPr algn="l"/>
+            <a:r>
+              <a:rPr b="1" sz="1050">
+                <a:solidFill>
+                  <a:srgbClr val="378648"/>
+                </a:solidFill>
+              </a:rPr>
+              <a:t>Fortaleza</a:t>
+            </a:r>
+          </a:p>
+          <a:p>
+            <a:pPr algn="l"/>
+            <a:r>
+              <a:rPr b="0" sz="1000">
+                <a:solidFill>
+                  <a:srgbClr val="404040"/>
+                </a:solidFill>
+              </a:rPr>
+              <a:t>Búsqueda de línea garantiza que cada paso mejora (en funciones suaves).</a:t>
+            </a:r>
+          </a:p>
+          <a:p>
+            <a:pPr algn="l"/>
+            <a:r>
+              <a:rPr b="0" sz="600">
+                <a:solidFill>
+                  <a:srgbClr val="404040"/>
+                </a:solidFill>
+              </a:rPr>
+              <a:t> </a:t>
+            </a:r>
+          </a:p>
+          <a:p>
+            <a:pPr algn="l"/>
+            <a:r>
+              <a:rPr b="1" sz="1050">
+                <a:solidFill>
+                  <a:srgbClr val="C55A11"/>
+                </a:solidFill>
+              </a:rPr>
+              <a:t>Debilidad</a:t>
+            </a:r>
+          </a:p>
+          <a:p>
+            <a:pPr algn="l"/>
+            <a:r>
+              <a:rPr b="0" sz="1000">
+                <a:solidFill>
+                  <a:srgbClr val="404040"/>
+                </a:solidFill>
+              </a:rPr>
+              <a:t>El criterio de Armijo colapsa con ruido alto. Costosísimo: 2d eval/iter (24 aquí).</a:t>
+            </a:r>
+          </a:p>
+          <a:p>
+            <a:pPr algn="l"/>
+            <a:r>
+              <a:rPr b="0" sz="600">
+                <a:solidFill>
+                  <a:srgbClr val="404040"/>
+                </a:solidFill>
+              </a:rPr>
+              <a:t> </a:t>
+            </a:r>
+          </a:p>
+          <a:p>
+            <a:pPr algn="l"/>
+            <a:r>
+              <a:rPr b="1" sz="1050">
+                <a:solidFill>
+                  <a:srgbClr val="404040"/>
+                </a:solidFill>
+              </a:rPr>
+              <a:t>Resultado obtenido</a:t>
+            </a:r>
+          </a:p>
+          <a:p>
+            <a:pPr algn="l"/>
+            <a:r>
+              <a:rPr b="0" sz="1000">
+                <a:solidFill>
+                  <a:srgbClr val="404040"/>
+                </a:solidFill>
+              </a:rPr>
+              <a:t>270.73 días — sin mejora tras 69.5 horas. Armijo rechazado en 30/30 iteraciones.</a:t>
+            </a:r>
+          </a:p>
+          <a:p>
+            <a:pPr algn="l"/>
+            <a:r>
+              <a:rPr b="0" sz="600">
+                <a:solidFill>
+                  <a:srgbClr val="404040"/>
+                </a:solidFill>
+              </a:rPr>
+              <a:t> </a:t>
+            </a:r>
+          </a:p>
+        </p:txBody>
+      </p:sp>
+      <p:sp>
+        <p:nvSpPr>
+          <p:cNvPr id="6" name="Rectangle 5"/>
+          <p:cNvSpPr/>
+          <p:nvPr/>
+        </p:nvSpPr>
+        <p:spPr>
+          <a:xfrm>
+            <a:off x="7543800" y="1719072"/>
+            <a:ext cx="36576" cy="4892040"/>
+          </a:xfrm>
+          <a:prstGeom prst="rect">
+            <a:avLst/>
+          </a:prstGeom>
+          <a:solidFill>
+            <a:srgbClr val="1F497D"/>
+          </a:solidFill>
+          <a:ln>
+            <a:noFill/>
+          </a:ln>
+        </p:spPr>
+        <p:style>
+          <a:lnRef idx="1">
+            <a:schemeClr val="accent1"/>
+          </a:lnRef>
+          <a:fillRef idx="3">
+            <a:schemeClr val="accent1"/>
+          </a:fillRef>
+          <a:effectRef idx="2">
+            <a:schemeClr val="accent1"/>
+          </a:effectRef>
+          <a:fontRef idx="minor">
+            <a:schemeClr val="lt1"/>
+          </a:fontRef>
+        </p:style>
+        <p:txBody>
+          <a:bodyPr rtlCol="0" anchor="ctr"/>
+          <a:lstStyle/>
+          <a:p>
+            <a:pPr algn="ctr"/>
+          </a:p>
+        </p:txBody>
+      </p:sp>
+      <p:sp>
+        <p:nvSpPr>
+          <p:cNvPr id="7" name="TextBox 6"/>
+          <p:cNvSpPr txBox="1"/>
+          <p:nvPr/>
+        </p:nvSpPr>
+        <p:spPr>
+          <a:xfrm>
+            <a:off x="274320" y="4663440"/>
+            <a:ext cx="7223760" cy="594360"/>
+          </a:xfrm>
+          <a:prstGeom prst="rect">
+            <a:avLst/>
+          </a:prstGeom>
+          <a:noFill/>
+        </p:spPr>
+        <p:txBody>
+          <a:bodyPr wrap="square">
+            <a:spAutoFit/>
+          </a:bodyPr>
+          <a:lstStyle/>
+          <a:p>
+            <a:pPr algn="l"/>
+            <a:r>
+              <a:rPr b="0" sz="850">
+                <a:solidFill>
+                  <a:srgbClr val="808080"/>
+                </a:solidFill>
+              </a:rPr>
+              <a:t>Referencia: Rojas-Gonzalez &amp; Van Nieuwenhuyse (2020) — «A Survey on Kriging-Based Infill Algorithms for Multiobjective Simulation Optimization» / «ALOE: Adaptive Level-set Oracle Estimation» — European Journal of Operational Research</a:t>
             </a:r>
           </a:p>
         </p:txBody>

</xml_diff>